<commit_message>
fix(presentation): finalize deck, real member photos, asset paths
- slide 2: use the two real member photos (1.jpg / 2.jpg) instead of the one
  duplicated avatar; make_assets.py crops them to public/avatar_*_round.png,
  make_team_slide.py uses a photo per member (avatar 180px, name 28px, QR 80px)
- slide 5: add the sixth chain step ("повторная проверка")
- fix screenshot paths: /public/screenshot-*.png 404s in the built deck, use
  /screenshot-*.png; guard it in tests/project/test_presentation_sync.py
- video: presentation/public/screencast.mp4 is now a symlink to the committed
  presentation/screencast.mp4 (no second copy)
- drop the dead team-avatar-round/square assets and their generator code
- sync README, CHANGELOG, VIDEO, verification docs, checksums to 19 slides,
  2:22 video, final palette; include the member photos in the submission archive
</commit_message>
<xml_diff>
--- a/presentation/team-slide.pptx
+++ b/presentation/team-slide.pptx
@@ -3301,7 +3301,7 @@
       </p:sp>
       <p:pic>
         <p:nvPicPr>
-          <p:cNvPr id="7" name="Picture 6" descr="team-avatar-round.png"/>
+          <p:cNvPr id="7" name="Picture 6" descr="avatar_pavel_round.png"/>
           <p:cNvPicPr>
             <a:picLocks noChangeAspect="1"/>
           </p:cNvPicPr>
@@ -3510,14 +3510,14 @@
       </p:sp>
       <p:pic>
         <p:nvPicPr>
-          <p:cNvPr id="13" name="Picture 12" descr="team-avatar-round.png"/>
+          <p:cNvPr id="13" name="Picture 12" descr="avatar_nikita_round.png"/>
           <p:cNvPicPr>
             <a:picLocks noChangeAspect="1"/>
           </p:cNvPicPr>
           <p:nvPr/>
         </p:nvPicPr>
         <p:blipFill>
-          <a:blip r:embed="rId2"/>
+          <a:blip r:embed="rId4"/>
           <a:stretch>
             <a:fillRect/>
           </a:stretch>
@@ -3658,7 +3658,7 @@
           <p:nvPr/>
         </p:nvPicPr>
         <p:blipFill>
-          <a:blip r:embed="rId4"/>
+          <a:blip r:embed="rId5"/>
           <a:stretch>
             <a:fillRect/>
           </a:stretch>
@@ -3942,7 +3942,7 @@
       </p:sp>
       <p:pic>
         <p:nvPicPr>
-          <p:cNvPr id="7" name="Picture 6" descr="team-avatar-round.png"/>
+          <p:cNvPr id="7" name="Picture 6" descr="avatar_pavel_round.png"/>
           <p:cNvPicPr>
             <a:picLocks noChangeAspect="1"/>
           </p:cNvPicPr>
@@ -4151,14 +4151,14 @@
       </p:sp>
       <p:pic>
         <p:nvPicPr>
-          <p:cNvPr id="13" name="Picture 12" descr="team-avatar-round.png"/>
+          <p:cNvPr id="13" name="Picture 12" descr="avatar_nikita_round.png"/>
           <p:cNvPicPr>
             <a:picLocks noChangeAspect="1"/>
           </p:cNvPicPr>
           <p:nvPr/>
         </p:nvPicPr>
         <p:blipFill>
-          <a:blip r:embed="rId2"/>
+          <a:blip r:embed="rId4"/>
           <a:stretch>
             <a:fillRect/>
           </a:stretch>
@@ -4299,7 +4299,7 @@
           <p:nvPr/>
         </p:nvPicPr>
         <p:blipFill>
-          <a:blip r:embed="rId4"/>
+          <a:blip r:embed="rId5"/>
           <a:stretch>
             <a:fillRect/>
           </a:stretch>

</xml_diff>